<commit_message>
bump studio to 0.7.0
</commit_message>
<xml_diff>
--- a/architecture/viewer-ecosystem.pptx
+++ b/architecture/viewer-ecosystem.pptx
@@ -262,7 +262,7 @@
           <a:p>
             <a:fld id="{77191D7D-AB0C-854E-97E0-BC94A1E8DDD6}" type="datetimeFigureOut">
               <a:rPr lang="en-DE" smtClean="0"/>
-              <a:t>9/16/26</a:t>
+              <a:t>9/17/26</a:t>
             </a:fld>
             <a:endParaRPr lang="en-DE"/>
           </a:p>
@@ -462,7 +462,7 @@
           <a:p>
             <a:fld id="{77191D7D-AB0C-854E-97E0-BC94A1E8DDD6}" type="datetimeFigureOut">
               <a:rPr lang="en-DE" smtClean="0"/>
-              <a:t>9/16/26</a:t>
+              <a:t>9/17/26</a:t>
             </a:fld>
             <a:endParaRPr lang="en-DE"/>
           </a:p>
@@ -672,7 +672,7 @@
           <a:p>
             <a:fld id="{77191D7D-AB0C-854E-97E0-BC94A1E8DDD6}" type="datetimeFigureOut">
               <a:rPr lang="en-DE" smtClean="0"/>
-              <a:t>9/16/26</a:t>
+              <a:t>9/17/26</a:t>
             </a:fld>
             <a:endParaRPr lang="en-DE"/>
           </a:p>
@@ -872,7 +872,7 @@
           <a:p>
             <a:fld id="{77191D7D-AB0C-854E-97E0-BC94A1E8DDD6}" type="datetimeFigureOut">
               <a:rPr lang="en-DE" smtClean="0"/>
-              <a:t>9/16/26</a:t>
+              <a:t>9/17/26</a:t>
             </a:fld>
             <a:endParaRPr lang="en-DE"/>
           </a:p>
@@ -1148,7 +1148,7 @@
           <a:p>
             <a:fld id="{77191D7D-AB0C-854E-97E0-BC94A1E8DDD6}" type="datetimeFigureOut">
               <a:rPr lang="en-DE" smtClean="0"/>
-              <a:t>9/16/26</a:t>
+              <a:t>9/17/26</a:t>
             </a:fld>
             <a:endParaRPr lang="en-DE"/>
           </a:p>
@@ -1416,7 +1416,7 @@
           <a:p>
             <a:fld id="{77191D7D-AB0C-854E-97E0-BC94A1E8DDD6}" type="datetimeFigureOut">
               <a:rPr lang="en-DE" smtClean="0"/>
-              <a:t>9/16/26</a:t>
+              <a:t>9/17/26</a:t>
             </a:fld>
             <a:endParaRPr lang="en-DE"/>
           </a:p>
@@ -1831,7 +1831,7 @@
           <a:p>
             <a:fld id="{77191D7D-AB0C-854E-97E0-BC94A1E8DDD6}" type="datetimeFigureOut">
               <a:rPr lang="en-DE" smtClean="0"/>
-              <a:t>9/16/26</a:t>
+              <a:t>9/17/26</a:t>
             </a:fld>
             <a:endParaRPr lang="en-DE"/>
           </a:p>
@@ -1973,7 +1973,7 @@
           <a:p>
             <a:fld id="{77191D7D-AB0C-854E-97E0-BC94A1E8DDD6}" type="datetimeFigureOut">
               <a:rPr lang="en-DE" smtClean="0"/>
-              <a:t>9/16/26</a:t>
+              <a:t>9/17/26</a:t>
             </a:fld>
             <a:endParaRPr lang="en-DE"/>
           </a:p>
@@ -2086,7 +2086,7 @@
           <a:p>
             <a:fld id="{77191D7D-AB0C-854E-97E0-BC94A1E8DDD6}" type="datetimeFigureOut">
               <a:rPr lang="en-DE" smtClean="0"/>
-              <a:t>9/16/26</a:t>
+              <a:t>9/17/26</a:t>
             </a:fld>
             <a:endParaRPr lang="en-DE"/>
           </a:p>
@@ -2399,7 +2399,7 @@
           <a:p>
             <a:fld id="{77191D7D-AB0C-854E-97E0-BC94A1E8DDD6}" type="datetimeFigureOut">
               <a:rPr lang="en-DE" smtClean="0"/>
-              <a:t>9/16/26</a:t>
+              <a:t>9/17/26</a:t>
             </a:fld>
             <a:endParaRPr lang="en-DE"/>
           </a:p>
@@ -2688,7 +2688,7 @@
           <a:p>
             <a:fld id="{77191D7D-AB0C-854E-97E0-BC94A1E8DDD6}" type="datetimeFigureOut">
               <a:rPr lang="en-DE" smtClean="0"/>
-              <a:t>9/16/26</a:t>
+              <a:t>9/17/26</a:t>
             </a:fld>
             <a:endParaRPr lang="en-DE"/>
           </a:p>
@@ -2931,7 +2931,7 @@
           <a:p>
             <a:fld id="{77191D7D-AB0C-854E-97E0-BC94A1E8DDD6}" type="datetimeFigureOut">
               <a:rPr lang="en-DE" smtClean="0"/>
-              <a:t>9/16/26</a:t>
+              <a:t>9/17/26</a:t>
             </a:fld>
             <a:endParaRPr lang="en-DE"/>
           </a:p>
@@ -4063,7 +4063,7 @@
                 <a:ea typeface="+mn-ea"/>
                 <a:cs typeface="+mn-cs"/>
               </a:rPr>
-              <a:t>(0.6.5)</a:t>
+              <a:t>(0.7.0)</a:t>
             </a:r>
             <a:endParaRPr lang="en-DE" sz="1600" b="1" dirty="0">
               <a:solidFill>
@@ -4505,7 +4505,7 @@
                 <a:ea typeface="+mn-ea"/>
                 <a:cs typeface="+mn-cs"/>
               </a:rPr>
-              <a:t>(5.0.6)</a:t>
+              <a:t>(5.0.7)</a:t>
             </a:r>
             <a:endParaRPr lang="en-DE" sz="1000" b="1" dirty="0">
               <a:solidFill>
@@ -8752,7 +8752,7 @@
           <a:p>
             <a:r>
               <a:rPr lang="en-US" dirty="0"/>
-              <a:t>2026-09-16</a:t>
+              <a:t>2026-09-17</a:t>
             </a:r>
           </a:p>
         </p:txBody>
@@ -9508,7 +9508,7 @@
                 <a:ea typeface="+mn-ea"/>
                 <a:cs typeface="+mn-cs"/>
               </a:rPr>
-              <a:t>(0.6.5)</a:t>
+              <a:t>(0.7.0)</a:t>
             </a:r>
             <a:endParaRPr lang="en-DE" sz="1600" b="1" dirty="0">
               <a:solidFill>
@@ -9950,7 +9950,7 @@
                 <a:ea typeface="+mn-ea"/>
                 <a:cs typeface="+mn-cs"/>
               </a:rPr>
-              <a:t>(5.0.6)</a:t>
+              <a:t>(5.0.7)</a:t>
             </a:r>
             <a:endParaRPr lang="en-DE" sz="1000" b="1" dirty="0">
               <a:solidFill>
@@ -12867,7 +12867,7 @@
           <a:p>
             <a:r>
               <a:rPr lang="en-US" dirty="0"/>
-              <a:t>2026-09-16</a:t>
+              <a:t>2026-09-17</a:t>
             </a:r>
           </a:p>
         </p:txBody>

</xml_diff>

<commit_message>
build123d Studio 0.7.1: the chapter follows the release
The window: the drawn scrollbar on the toolbar and the tab strip, preview
tabs and what keeps one, picture tabs, Interrupt on an idle kernel, the
Makefile row's menu, Stop while anything runs, a selection that stays in
its tab. The editor: pictures in the file-type table. Running code: the
Stop button, which show import reaches Studio from a script and which does
not, the PATH a run gets, a Make section. Packages: the git check's new
behaviour. Troubleshooting: a Makefile target's "command not found" and a
missing Make entry.

The viewer-ecosystem diagram is updated alongside.

Co-Authored-By: Claude Opus 5 (1M context) <noreply@anthropic.com>
</commit_message>
<xml_diff>
--- a/architecture/viewer-ecosystem.pptx
+++ b/architecture/viewer-ecosystem.pptx
@@ -262,7 +262,7 @@
           <a:p>
             <a:fld id="{77191D7D-AB0C-854E-97E0-BC94A1E8DDD6}" type="datetimeFigureOut">
               <a:rPr lang="en-DE" smtClean="0"/>
-              <a:t>9/17/26</a:t>
+              <a:t>9/18/26</a:t>
             </a:fld>
             <a:endParaRPr lang="en-DE"/>
           </a:p>
@@ -462,7 +462,7 @@
           <a:p>
             <a:fld id="{77191D7D-AB0C-854E-97E0-BC94A1E8DDD6}" type="datetimeFigureOut">
               <a:rPr lang="en-DE" smtClean="0"/>
-              <a:t>9/17/26</a:t>
+              <a:t>9/18/26</a:t>
             </a:fld>
             <a:endParaRPr lang="en-DE"/>
           </a:p>
@@ -672,7 +672,7 @@
           <a:p>
             <a:fld id="{77191D7D-AB0C-854E-97E0-BC94A1E8DDD6}" type="datetimeFigureOut">
               <a:rPr lang="en-DE" smtClean="0"/>
-              <a:t>9/17/26</a:t>
+              <a:t>9/18/26</a:t>
             </a:fld>
             <a:endParaRPr lang="en-DE"/>
           </a:p>
@@ -872,7 +872,7 @@
           <a:p>
             <a:fld id="{77191D7D-AB0C-854E-97E0-BC94A1E8DDD6}" type="datetimeFigureOut">
               <a:rPr lang="en-DE" smtClean="0"/>
-              <a:t>9/17/26</a:t>
+              <a:t>9/18/26</a:t>
             </a:fld>
             <a:endParaRPr lang="en-DE"/>
           </a:p>
@@ -1148,7 +1148,7 @@
           <a:p>
             <a:fld id="{77191D7D-AB0C-854E-97E0-BC94A1E8DDD6}" type="datetimeFigureOut">
               <a:rPr lang="en-DE" smtClean="0"/>
-              <a:t>9/17/26</a:t>
+              <a:t>9/18/26</a:t>
             </a:fld>
             <a:endParaRPr lang="en-DE"/>
           </a:p>
@@ -1416,7 +1416,7 @@
           <a:p>
             <a:fld id="{77191D7D-AB0C-854E-97E0-BC94A1E8DDD6}" type="datetimeFigureOut">
               <a:rPr lang="en-DE" smtClean="0"/>
-              <a:t>9/17/26</a:t>
+              <a:t>9/18/26</a:t>
             </a:fld>
             <a:endParaRPr lang="en-DE"/>
           </a:p>
@@ -1831,7 +1831,7 @@
           <a:p>
             <a:fld id="{77191D7D-AB0C-854E-97E0-BC94A1E8DDD6}" type="datetimeFigureOut">
               <a:rPr lang="en-DE" smtClean="0"/>
-              <a:t>9/17/26</a:t>
+              <a:t>9/18/26</a:t>
             </a:fld>
             <a:endParaRPr lang="en-DE"/>
           </a:p>
@@ -1973,7 +1973,7 @@
           <a:p>
             <a:fld id="{77191D7D-AB0C-854E-97E0-BC94A1E8DDD6}" type="datetimeFigureOut">
               <a:rPr lang="en-DE" smtClean="0"/>
-              <a:t>9/17/26</a:t>
+              <a:t>9/18/26</a:t>
             </a:fld>
             <a:endParaRPr lang="en-DE"/>
           </a:p>
@@ -2086,7 +2086,7 @@
           <a:p>
             <a:fld id="{77191D7D-AB0C-854E-97E0-BC94A1E8DDD6}" type="datetimeFigureOut">
               <a:rPr lang="en-DE" smtClean="0"/>
-              <a:t>9/17/26</a:t>
+              <a:t>9/18/26</a:t>
             </a:fld>
             <a:endParaRPr lang="en-DE"/>
           </a:p>
@@ -2399,7 +2399,7 @@
           <a:p>
             <a:fld id="{77191D7D-AB0C-854E-97E0-BC94A1E8DDD6}" type="datetimeFigureOut">
               <a:rPr lang="en-DE" smtClean="0"/>
-              <a:t>9/17/26</a:t>
+              <a:t>9/18/26</a:t>
             </a:fld>
             <a:endParaRPr lang="en-DE"/>
           </a:p>
@@ -2688,7 +2688,7 @@
           <a:p>
             <a:fld id="{77191D7D-AB0C-854E-97E0-BC94A1E8DDD6}" type="datetimeFigureOut">
               <a:rPr lang="en-DE" smtClean="0"/>
-              <a:t>9/17/26</a:t>
+              <a:t>9/18/26</a:t>
             </a:fld>
             <a:endParaRPr lang="en-DE"/>
           </a:p>
@@ -2931,7 +2931,7 @@
           <a:p>
             <a:fld id="{77191D7D-AB0C-854E-97E0-BC94A1E8DDD6}" type="datetimeFigureOut">
               <a:rPr lang="en-DE" smtClean="0"/>
-              <a:t>9/17/26</a:t>
+              <a:t>9/18/26</a:t>
             </a:fld>
             <a:endParaRPr lang="en-DE"/>
           </a:p>
@@ -4063,7 +4063,7 @@
                 <a:ea typeface="+mn-ea"/>
                 <a:cs typeface="+mn-cs"/>
               </a:rPr>
-              <a:t>(0.7.0)</a:t>
+              <a:t>(0.7.1)</a:t>
             </a:r>
             <a:endParaRPr lang="en-DE" sz="1600" b="1" dirty="0">
               <a:solidFill>
@@ -8752,7 +8752,7 @@
           <a:p>
             <a:r>
               <a:rPr lang="en-US" dirty="0"/>
-              <a:t>2026-09-17</a:t>
+              <a:t>2026-09-18</a:t>
             </a:r>
           </a:p>
         </p:txBody>
@@ -9508,7 +9508,7 @@
                 <a:ea typeface="+mn-ea"/>
                 <a:cs typeface="+mn-cs"/>
               </a:rPr>
-              <a:t>(0.7.0)</a:t>
+              <a:t>(0.7.1)</a:t>
             </a:r>
             <a:endParaRPr lang="en-DE" sz="1600" b="1" dirty="0">
               <a:solidFill>
@@ -12867,7 +12867,7 @@
           <a:p>
             <a:r>
               <a:rPr lang="en-US" dirty="0"/>
-              <a:t>2026-09-17</a:t>
+              <a:t>2026-09-18</a:t>
             </a:r>
           </a:p>
         </p:txBody>

</xml_diff>

<commit_message>
Architecture diagram: the versions of 2026-10-13
ocp_viewer 1.2.0, ocp_vscode 4.2.0, build123d_studio 0.9.0, jupyter_cadquery
5.2.0, ocp-viewer-core 1.1.2 (Python) / 1.1.0 (JavaScript), ocp-tessellate
3.6.2, cad_viewer_widget 4.2.0, three-cad-viewer 5.1.3.

Co-Authored-By: Claude Opus 5.5 <noreply@anthropic.com>
</commit_message>
<xml_diff>
--- a/architecture/viewer-ecosystem.pptx
+++ b/architecture/viewer-ecosystem.pptx
@@ -262,7 +262,7 @@
           <a:p>
             <a:fld id="{77191D7D-AB0C-854E-97E0-BC94A1E8DDD6}" type="datetimeFigureOut">
               <a:rPr lang="en-DE" smtClean="0"/>
-              <a:t>9/21/26</a:t>
+              <a:t>13.10.26</a:t>
             </a:fld>
             <a:endParaRPr lang="en-DE"/>
           </a:p>
@@ -462,7 +462,7 @@
           <a:p>
             <a:fld id="{77191D7D-AB0C-854E-97E0-BC94A1E8DDD6}" type="datetimeFigureOut">
               <a:rPr lang="en-DE" smtClean="0"/>
-              <a:t>9/21/26</a:t>
+              <a:t>13.10.26</a:t>
             </a:fld>
             <a:endParaRPr lang="en-DE"/>
           </a:p>
@@ -672,7 +672,7 @@
           <a:p>
             <a:fld id="{77191D7D-AB0C-854E-97E0-BC94A1E8DDD6}" type="datetimeFigureOut">
               <a:rPr lang="en-DE" smtClean="0"/>
-              <a:t>9/21/26</a:t>
+              <a:t>13.10.26</a:t>
             </a:fld>
             <a:endParaRPr lang="en-DE"/>
           </a:p>
@@ -872,7 +872,7 @@
           <a:p>
             <a:fld id="{77191D7D-AB0C-854E-97E0-BC94A1E8DDD6}" type="datetimeFigureOut">
               <a:rPr lang="en-DE" smtClean="0"/>
-              <a:t>9/21/26</a:t>
+              <a:t>13.10.26</a:t>
             </a:fld>
             <a:endParaRPr lang="en-DE"/>
           </a:p>
@@ -1148,7 +1148,7 @@
           <a:p>
             <a:fld id="{77191D7D-AB0C-854E-97E0-BC94A1E8DDD6}" type="datetimeFigureOut">
               <a:rPr lang="en-DE" smtClean="0"/>
-              <a:t>9/21/26</a:t>
+              <a:t>13.10.26</a:t>
             </a:fld>
             <a:endParaRPr lang="en-DE"/>
           </a:p>
@@ -1416,7 +1416,7 @@
           <a:p>
             <a:fld id="{77191D7D-AB0C-854E-97E0-BC94A1E8DDD6}" type="datetimeFigureOut">
               <a:rPr lang="en-DE" smtClean="0"/>
-              <a:t>9/21/26</a:t>
+              <a:t>13.10.26</a:t>
             </a:fld>
             <a:endParaRPr lang="en-DE"/>
           </a:p>
@@ -1831,7 +1831,7 @@
           <a:p>
             <a:fld id="{77191D7D-AB0C-854E-97E0-BC94A1E8DDD6}" type="datetimeFigureOut">
               <a:rPr lang="en-DE" smtClean="0"/>
-              <a:t>9/21/26</a:t>
+              <a:t>13.10.26</a:t>
             </a:fld>
             <a:endParaRPr lang="en-DE"/>
           </a:p>
@@ -1973,7 +1973,7 @@
           <a:p>
             <a:fld id="{77191D7D-AB0C-854E-97E0-BC94A1E8DDD6}" type="datetimeFigureOut">
               <a:rPr lang="en-DE" smtClean="0"/>
-              <a:t>9/21/26</a:t>
+              <a:t>13.10.26</a:t>
             </a:fld>
             <a:endParaRPr lang="en-DE"/>
           </a:p>
@@ -2086,7 +2086,7 @@
           <a:p>
             <a:fld id="{77191D7D-AB0C-854E-97E0-BC94A1E8DDD6}" type="datetimeFigureOut">
               <a:rPr lang="en-DE" smtClean="0"/>
-              <a:t>9/21/26</a:t>
+              <a:t>13.10.26</a:t>
             </a:fld>
             <a:endParaRPr lang="en-DE"/>
           </a:p>
@@ -2399,7 +2399,7 @@
           <a:p>
             <a:fld id="{77191D7D-AB0C-854E-97E0-BC94A1E8DDD6}" type="datetimeFigureOut">
               <a:rPr lang="en-DE" smtClean="0"/>
-              <a:t>9/21/26</a:t>
+              <a:t>13.10.26</a:t>
             </a:fld>
             <a:endParaRPr lang="en-DE"/>
           </a:p>
@@ -2688,7 +2688,7 @@
           <a:p>
             <a:fld id="{77191D7D-AB0C-854E-97E0-BC94A1E8DDD6}" type="datetimeFigureOut">
               <a:rPr lang="en-DE" smtClean="0"/>
-              <a:t>9/21/26</a:t>
+              <a:t>13.10.26</a:t>
             </a:fld>
             <a:endParaRPr lang="en-DE"/>
           </a:p>
@@ -2931,7 +2931,7 @@
           <a:p>
             <a:fld id="{77191D7D-AB0C-854E-97E0-BC94A1E8DDD6}" type="datetimeFigureOut">
               <a:rPr lang="en-DE" smtClean="0"/>
-              <a:t>9/21/26</a:t>
+              <a:t>13.10.26</a:t>
             </a:fld>
             <a:endParaRPr lang="en-DE"/>
           </a:p>
@@ -3493,7 +3493,7 @@
                 <a:ea typeface="+mn-ea"/>
                 <a:cs typeface="+mn-cs"/>
               </a:rPr>
-              <a:t>(1.0.13)</a:t>
+              <a:t>(1.1.2)</a:t>
             </a:r>
             <a:endParaRPr lang="en-DE" sz="1600" b="1" dirty="0">
               <a:solidFill>
@@ -3630,7 +3630,7 @@
                   </a:schemeClr>
                 </a:solidFill>
               </a:rPr>
-              <a:t>(1.1.3)</a:t>
+              <a:t>(1.2.0)</a:t>
             </a:r>
             <a:endParaRPr lang="en-DE" sz="1000" b="1" dirty="0">
               <a:solidFill>
@@ -3739,7 +3739,7 @@
                 <a:ea typeface="+mn-ea"/>
                 <a:cs typeface="+mn-cs"/>
               </a:rPr>
-              <a:t>(5.1.0)</a:t>
+              <a:t>(5.2.0)</a:t>
             </a:r>
             <a:endParaRPr lang="en-DE" sz="1600" b="1" dirty="0">
               <a:solidFill>
@@ -3845,7 +3845,7 @@
                 <a:ea typeface="+mn-ea"/>
                 <a:cs typeface="+mn-cs"/>
               </a:rPr>
-              <a:t>(4.1.5)</a:t>
+              <a:t>(4.2.0)</a:t>
             </a:r>
             <a:endParaRPr lang="en-DE" sz="1600" b="1" dirty="0">
               <a:solidFill>
@@ -3954,7 +3954,7 @@
                 <a:ea typeface="+mn-ea"/>
                 <a:cs typeface="+mn-cs"/>
               </a:rPr>
-              <a:t>(4.1.0)</a:t>
+              <a:t>(4.2.0)</a:t>
             </a:r>
             <a:endParaRPr lang="en-DE" sz="1600" dirty="0">
               <a:solidFill>
@@ -4063,7 +4063,7 @@
                 <a:ea typeface="+mn-ea"/>
                 <a:cs typeface="+mn-cs"/>
               </a:rPr>
-              <a:t>(0.8.0)</a:t>
+              <a:t>(0.9.0)</a:t>
             </a:r>
             <a:endParaRPr lang="en-DE" sz="1600" b="1" dirty="0">
               <a:solidFill>
@@ -4169,7 +4169,7 @@
                 <a:ea typeface="+mn-ea"/>
                 <a:cs typeface="+mn-cs"/>
               </a:rPr>
-              <a:t>(3.5.3)</a:t>
+              <a:t>(3.6.2)</a:t>
             </a:r>
             <a:endParaRPr lang="en-DE" sz="1600" b="1" dirty="0">
               <a:solidFill>
@@ -4505,7 +4505,7 @@
                 <a:ea typeface="+mn-ea"/>
                 <a:cs typeface="+mn-cs"/>
               </a:rPr>
-              <a:t>(5.0.7)</a:t>
+              <a:t>(5.1.3)</a:t>
             </a:r>
             <a:endParaRPr lang="en-DE" sz="1000" b="1" dirty="0">
               <a:solidFill>
@@ -4658,7 +4658,7 @@
                 <a:ea typeface="+mn-ea"/>
                 <a:cs typeface="+mn-cs"/>
               </a:rPr>
-              <a:t>(1.0.4)</a:t>
+              <a:t>(1.1.0)</a:t>
             </a:r>
             <a:endParaRPr lang="en-DE" sz="1600" b="1" dirty="0">
               <a:solidFill>
@@ -5836,7 +5836,7 @@
                 <a:ea typeface="+mn-ea"/>
                 <a:cs typeface="+mn-cs"/>
               </a:rPr>
-              <a:t>(4.1.5)</a:t>
+              <a:t>(4.2.0)</a:t>
             </a:r>
             <a:endParaRPr lang="en-DE" sz="1600" b="1" dirty="0">
               <a:solidFill>
@@ -8737,7 +8737,7 @@
         <p:spPr>
           <a:xfrm>
             <a:off x="296902" y="298533"/>
-            <a:ext cx="1311834" cy="369332"/>
+            <a:ext cx="1294457" cy="369332"/>
           </a:xfrm>
           <a:prstGeom prst="rect">
             <a:avLst/>
@@ -8752,7 +8752,7 @@
           <a:p>
             <a:r>
               <a:rPr lang="en-US" dirty="0"/>
-              <a:t>2026-09-18</a:t>
+              <a:t>2026-10-13</a:t>
             </a:r>
           </a:p>
         </p:txBody>

</xml_diff>